<commit_message>
Revue des 11 derniers comptes (hors Pour de Bon)
Co-Authored-By: Claude Opus 5.5 <noreply@anthropic.com>
Claude-Session: https://claude.ai/code/session_01BmxtdWjbeRUyPx9e1qVLbT
</commit_message>
<xml_diff>
--- a/rapports/septembre/DSR_sept2026.pptx
+++ b/rapports/septembre/DSR_sept2026.pptx
@@ -6891,7 +6891,7 @@
                 </a:solidFill>
                 <a:latin typeface="Arial"/>
               </a:rPr>
-              <a:t>L'achat d'une voiture, premier déclencheur</a:t>
+              <a:t>Mettre un chiffre dans le titre</a:t>
             </a:r>
           </a:p>
         </p:txBody>
@@ -6926,7 +6926,7 @@
                 </a:solidFill>
                 <a:latin typeface="Arial"/>
               </a:rPr>
-              <a:t>41 % des conversations du secteur sont déclenchées par l'achat d'une voiture, devant la vie en van et les départs en vacances (17 % chacun).</a:t>
+              <a:t>Le titre met en avant l'âge (« 15 ans, c'est le bon moment ») ; les bénéfices chiffrés (3 000 km au volant) ne figurent que dans la description.</a:t>
             </a:r>
           </a:p>
         </p:txBody>
@@ -6961,7 +6961,7 @@
                 </a:solidFill>
                 <a:latin typeface="Arial"/>
               </a:rPr>
-              <a:t>→  Relier la conduite accompagnée au futur premier véhicule : « Préparez le permis avant la première voiture ».</a:t>
+              <a:t>→  Tester un titre avec un bénéfice chiffré : « 3 000 km au volant avant le permis ».</a:t>
             </a:r>
           </a:p>
         </p:txBody>

</xml_diff>